<commit_message>
Updates and improvements to slides
</commit_message>
<xml_diff>
--- a/LectureSlides/07_IntroductionToBayesModels.pptx
+++ b/LectureSlides/07_IntroductionToBayesModels.pptx
@@ -5,7 +5,7 @@
     <p:sldMasterId id="2147483648" r:id="rId1"/>
   </p:sldMasterIdLst>
   <p:notesMasterIdLst>
-    <p:notesMasterId r:id="rId68"/>
+    <p:notesMasterId r:id="rId69"/>
   </p:notesMasterIdLst>
   <p:sldIdLst>
     <p:sldId id="301" r:id="rId2"/>
@@ -73,7 +73,8 @@
     <p:sldId id="318" r:id="rId64"/>
     <p:sldId id="298" r:id="rId65"/>
     <p:sldId id="299" r:id="rId66"/>
-    <p:sldId id="300" r:id="rId67"/>
+    <p:sldId id="327" r:id="rId67"/>
+    <p:sldId id="300" r:id="rId68"/>
   </p:sldIdLst>
   <p:sldSz cx="9144000" cy="5143500" type="screen16x9"/>
   <p:notesSz cx="6858000" cy="9144000"/>
@@ -273,7 +274,7 @@
           <a:p>
             <a:fld id="{13DDEE00-70AE-47E2-95E5-F1C95ECCE916}" type="datetimeFigureOut">
               <a:rPr lang="en-US" smtClean="0"/>
-              <a:t>10/11/2026</a:t>
+              <a:t>10/12/2026</a:t>
             </a:fld>
             <a:endParaRPr lang="en-US"/>
           </a:p>
@@ -803,7 +804,7 @@
           <a:p>
             <a:fld id="{241EB5C9-1307-BA42-ABA2-0BC069CD8E7F}" type="datetimeFigureOut">
               <a:rPr lang="en-US" smtClean="0"/>
-              <a:t>10/11/2026</a:t>
+              <a:t>10/12/2026</a:t>
             </a:fld>
             <a:endParaRPr lang="en-US"/>
           </a:p>
@@ -971,7 +972,7 @@
           <a:p>
             <a:fld id="{241EB5C9-1307-BA42-ABA2-0BC069CD8E7F}" type="datetimeFigureOut">
               <a:rPr lang="en-US" smtClean="0"/>
-              <a:t>10/11/2026</a:t>
+              <a:t>10/12/2026</a:t>
             </a:fld>
             <a:endParaRPr lang="en-US"/>
           </a:p>
@@ -1149,7 +1150,7 @@
           <a:p>
             <a:fld id="{241EB5C9-1307-BA42-ABA2-0BC069CD8E7F}" type="datetimeFigureOut">
               <a:rPr lang="en-US" smtClean="0"/>
-              <a:t>10/11/2026</a:t>
+              <a:t>10/12/2026</a:t>
             </a:fld>
             <a:endParaRPr lang="en-US"/>
           </a:p>
@@ -1317,7 +1318,7 @@
           <a:p>
             <a:fld id="{241EB5C9-1307-BA42-ABA2-0BC069CD8E7F}" type="datetimeFigureOut">
               <a:rPr lang="en-US" smtClean="0"/>
-              <a:t>10/11/2026</a:t>
+              <a:t>10/12/2026</a:t>
             </a:fld>
             <a:endParaRPr lang="en-US"/>
           </a:p>
@@ -1562,7 +1563,7 @@
           <a:p>
             <a:fld id="{241EB5C9-1307-BA42-ABA2-0BC069CD8E7F}" type="datetimeFigureOut">
               <a:rPr lang="en-US" smtClean="0"/>
-              <a:t>10/11/2026</a:t>
+              <a:t>10/12/2026</a:t>
             </a:fld>
             <a:endParaRPr lang="en-US"/>
           </a:p>
@@ -1847,7 +1848,7 @@
           <a:p>
             <a:fld id="{241EB5C9-1307-BA42-ABA2-0BC069CD8E7F}" type="datetimeFigureOut">
               <a:rPr lang="en-US" smtClean="0"/>
-              <a:t>10/11/2026</a:t>
+              <a:t>10/12/2026</a:t>
             </a:fld>
             <a:endParaRPr lang="en-US"/>
           </a:p>
@@ -2266,7 +2267,7 @@
           <a:p>
             <a:fld id="{241EB5C9-1307-BA42-ABA2-0BC069CD8E7F}" type="datetimeFigureOut">
               <a:rPr lang="en-US" smtClean="0"/>
-              <a:t>10/11/2026</a:t>
+              <a:t>10/12/2026</a:t>
             </a:fld>
             <a:endParaRPr lang="en-US"/>
           </a:p>
@@ -2383,7 +2384,7 @@
           <a:p>
             <a:fld id="{241EB5C9-1307-BA42-ABA2-0BC069CD8E7F}" type="datetimeFigureOut">
               <a:rPr lang="en-US" smtClean="0"/>
-              <a:t>10/11/2026</a:t>
+              <a:t>10/12/2026</a:t>
             </a:fld>
             <a:endParaRPr lang="en-US"/>
           </a:p>
@@ -2478,7 +2479,7 @@
           <a:p>
             <a:fld id="{241EB5C9-1307-BA42-ABA2-0BC069CD8E7F}" type="datetimeFigureOut">
               <a:rPr lang="en-US" smtClean="0"/>
-              <a:t>10/11/2026</a:t>
+              <a:t>10/12/2026</a:t>
             </a:fld>
             <a:endParaRPr lang="en-US"/>
           </a:p>
@@ -2753,7 +2754,7 @@
           <a:p>
             <a:fld id="{241EB5C9-1307-BA42-ABA2-0BC069CD8E7F}" type="datetimeFigureOut">
               <a:rPr lang="en-US" smtClean="0"/>
-              <a:t>10/11/2026</a:t>
+              <a:t>10/12/2026</a:t>
             </a:fld>
             <a:endParaRPr lang="en-US"/>
           </a:p>
@@ -3005,7 +3006,7 @@
           <a:p>
             <a:fld id="{241EB5C9-1307-BA42-ABA2-0BC069CD8E7F}" type="datetimeFigureOut">
               <a:rPr lang="en-US" smtClean="0"/>
-              <a:t>10/11/2026</a:t>
+              <a:t>10/12/2026</a:t>
             </a:fld>
             <a:endParaRPr lang="en-US"/>
           </a:p>
@@ -3216,7 +3217,7 @@
           <a:p>
             <a:fld id="{241EB5C9-1307-BA42-ABA2-0BC069CD8E7F}" type="datetimeFigureOut">
               <a:rPr lang="en-US" smtClean="0"/>
-              <a:t>10/11/2026</a:t>
+              <a:t>10/12/2026</a:t>
             </a:fld>
             <a:endParaRPr lang="en-US"/>
           </a:p>
@@ -13678,6 +13679,338 @@
   <p:clrMapOvr>
     <a:masterClrMapping/>
   </p:clrMapOvr>
+  <p:timing>
+    <p:tnLst>
+      <p:par>
+        <p:cTn id="1" dur="indefinite" restart="never" nodeType="tmRoot">
+          <p:childTnLst>
+            <p:seq concurrent="1" nextAc="seek">
+              <p:cTn id="2" dur="indefinite" nodeType="mainSeq">
+                <p:childTnLst>
+                  <p:par>
+                    <p:cTn id="3" fill="hold">
+                      <p:stCondLst>
+                        <p:cond delay="indefinite"/>
+                      </p:stCondLst>
+                      <p:childTnLst>
+                        <p:par>
+                          <p:cTn id="4" fill="hold">
+                            <p:stCondLst>
+                              <p:cond delay="0"/>
+                            </p:stCondLst>
+                            <p:childTnLst>
+                              <p:par>
+                                <p:cTn id="5" presetID="1" presetClass="entr" presetSubtype="0" fill="hold" nodeType="clickEffect">
+                                  <p:stCondLst>
+                                    <p:cond delay="0"/>
+                                  </p:stCondLst>
+                                  <p:childTnLst>
+                                    <p:set>
+                                      <p:cBhvr>
+                                        <p:cTn id="6" dur="1" fill="hold">
+                                          <p:stCondLst>
+                                            <p:cond delay="0"/>
+                                          </p:stCondLst>
+                                        </p:cTn>
+                                        <p:tgtEl>
+                                          <p:spTgt spid="3">
+                                            <p:txEl>
+                                              <p:pRg st="1" end="1"/>
+                                            </p:txEl>
+                                          </p:spTgt>
+                                        </p:tgtEl>
+                                        <p:attrNameLst>
+                                          <p:attrName>style.visibility</p:attrName>
+                                        </p:attrNameLst>
+                                      </p:cBhvr>
+                                      <p:to>
+                                        <p:strVal val="visible"/>
+                                      </p:to>
+                                    </p:set>
+                                  </p:childTnLst>
+                                </p:cTn>
+                              </p:par>
+                              <p:par>
+                                <p:cTn id="7" presetID="1" presetClass="entr" presetSubtype="0" fill="hold" nodeType="withEffect">
+                                  <p:stCondLst>
+                                    <p:cond delay="0"/>
+                                  </p:stCondLst>
+                                  <p:childTnLst>
+                                    <p:set>
+                                      <p:cBhvr>
+                                        <p:cTn id="8" dur="1" fill="hold">
+                                          <p:stCondLst>
+                                            <p:cond delay="0"/>
+                                          </p:stCondLst>
+                                        </p:cTn>
+                                        <p:tgtEl>
+                                          <p:spTgt spid="3">
+                                            <p:txEl>
+                                              <p:pRg st="2" end="2"/>
+                                            </p:txEl>
+                                          </p:spTgt>
+                                        </p:tgtEl>
+                                        <p:attrNameLst>
+                                          <p:attrName>style.visibility</p:attrName>
+                                        </p:attrNameLst>
+                                      </p:cBhvr>
+                                      <p:to>
+                                        <p:strVal val="visible"/>
+                                      </p:to>
+                                    </p:set>
+                                  </p:childTnLst>
+                                </p:cTn>
+                              </p:par>
+                            </p:childTnLst>
+                          </p:cTn>
+                        </p:par>
+                      </p:childTnLst>
+                    </p:cTn>
+                  </p:par>
+                  <p:par>
+                    <p:cTn id="9" fill="hold">
+                      <p:stCondLst>
+                        <p:cond delay="indefinite"/>
+                      </p:stCondLst>
+                      <p:childTnLst>
+                        <p:par>
+                          <p:cTn id="10" fill="hold">
+                            <p:stCondLst>
+                              <p:cond delay="0"/>
+                            </p:stCondLst>
+                            <p:childTnLst>
+                              <p:par>
+                                <p:cTn id="11" presetID="1" presetClass="entr" presetSubtype="0" fill="hold" nodeType="clickEffect">
+                                  <p:stCondLst>
+                                    <p:cond delay="0"/>
+                                  </p:stCondLst>
+                                  <p:childTnLst>
+                                    <p:set>
+                                      <p:cBhvr>
+                                        <p:cTn id="12" dur="1" fill="hold">
+                                          <p:stCondLst>
+                                            <p:cond delay="0"/>
+                                          </p:stCondLst>
+                                        </p:cTn>
+                                        <p:tgtEl>
+                                          <p:spTgt spid="3">
+                                            <p:txEl>
+                                              <p:pRg st="3" end="3"/>
+                                            </p:txEl>
+                                          </p:spTgt>
+                                        </p:tgtEl>
+                                        <p:attrNameLst>
+                                          <p:attrName>style.visibility</p:attrName>
+                                        </p:attrNameLst>
+                                      </p:cBhvr>
+                                      <p:to>
+                                        <p:strVal val="visible"/>
+                                      </p:to>
+                                    </p:set>
+                                  </p:childTnLst>
+                                </p:cTn>
+                              </p:par>
+                              <p:par>
+                                <p:cTn id="13" presetID="1" presetClass="entr" presetSubtype="0" fill="hold" nodeType="withEffect">
+                                  <p:stCondLst>
+                                    <p:cond delay="0"/>
+                                  </p:stCondLst>
+                                  <p:childTnLst>
+                                    <p:set>
+                                      <p:cBhvr>
+                                        <p:cTn id="14" dur="1" fill="hold">
+                                          <p:stCondLst>
+                                            <p:cond delay="0"/>
+                                          </p:stCondLst>
+                                        </p:cTn>
+                                        <p:tgtEl>
+                                          <p:spTgt spid="3">
+                                            <p:txEl>
+                                              <p:pRg st="4" end="4"/>
+                                            </p:txEl>
+                                          </p:spTgt>
+                                        </p:tgtEl>
+                                        <p:attrNameLst>
+                                          <p:attrName>style.visibility</p:attrName>
+                                        </p:attrNameLst>
+                                      </p:cBhvr>
+                                      <p:to>
+                                        <p:strVal val="visible"/>
+                                      </p:to>
+                                    </p:set>
+                                  </p:childTnLst>
+                                </p:cTn>
+                              </p:par>
+                              <p:par>
+                                <p:cTn id="15" presetID="1" presetClass="entr" presetSubtype="0" fill="hold" nodeType="withEffect">
+                                  <p:stCondLst>
+                                    <p:cond delay="0"/>
+                                  </p:stCondLst>
+                                  <p:childTnLst>
+                                    <p:set>
+                                      <p:cBhvr>
+                                        <p:cTn id="16" dur="1" fill="hold">
+                                          <p:stCondLst>
+                                            <p:cond delay="0"/>
+                                          </p:stCondLst>
+                                        </p:cTn>
+                                        <p:tgtEl>
+                                          <p:spTgt spid="3">
+                                            <p:txEl>
+                                              <p:pRg st="5" end="5"/>
+                                            </p:txEl>
+                                          </p:spTgt>
+                                        </p:tgtEl>
+                                        <p:attrNameLst>
+                                          <p:attrName>style.visibility</p:attrName>
+                                        </p:attrNameLst>
+                                      </p:cBhvr>
+                                      <p:to>
+                                        <p:strVal val="visible"/>
+                                      </p:to>
+                                    </p:set>
+                                  </p:childTnLst>
+                                </p:cTn>
+                              </p:par>
+                              <p:par>
+                                <p:cTn id="17" presetID="1" presetClass="entr" presetSubtype="0" fill="hold" nodeType="withEffect">
+                                  <p:stCondLst>
+                                    <p:cond delay="0"/>
+                                  </p:stCondLst>
+                                  <p:childTnLst>
+                                    <p:set>
+                                      <p:cBhvr>
+                                        <p:cTn id="18" dur="1" fill="hold">
+                                          <p:stCondLst>
+                                            <p:cond delay="0"/>
+                                          </p:stCondLst>
+                                        </p:cTn>
+                                        <p:tgtEl>
+                                          <p:spTgt spid="3">
+                                            <p:txEl>
+                                              <p:pRg st="6" end="6"/>
+                                            </p:txEl>
+                                          </p:spTgt>
+                                        </p:tgtEl>
+                                        <p:attrNameLst>
+                                          <p:attrName>style.visibility</p:attrName>
+                                        </p:attrNameLst>
+                                      </p:cBhvr>
+                                      <p:to>
+                                        <p:strVal val="visible"/>
+                                      </p:to>
+                                    </p:set>
+                                  </p:childTnLst>
+                                </p:cTn>
+                              </p:par>
+                            </p:childTnLst>
+                          </p:cTn>
+                        </p:par>
+                      </p:childTnLst>
+                    </p:cTn>
+                  </p:par>
+                  <p:par>
+                    <p:cTn id="19" fill="hold">
+                      <p:stCondLst>
+                        <p:cond delay="indefinite"/>
+                      </p:stCondLst>
+                      <p:childTnLst>
+                        <p:par>
+                          <p:cTn id="20" fill="hold">
+                            <p:stCondLst>
+                              <p:cond delay="0"/>
+                            </p:stCondLst>
+                            <p:childTnLst>
+                              <p:par>
+                                <p:cTn id="21" presetID="1" presetClass="entr" presetSubtype="0" fill="hold" nodeType="clickEffect">
+                                  <p:stCondLst>
+                                    <p:cond delay="0"/>
+                                  </p:stCondLst>
+                                  <p:childTnLst>
+                                    <p:set>
+                                      <p:cBhvr>
+                                        <p:cTn id="22" dur="1" fill="hold">
+                                          <p:stCondLst>
+                                            <p:cond delay="0"/>
+                                          </p:stCondLst>
+                                        </p:cTn>
+                                        <p:tgtEl>
+                                          <p:spTgt spid="3">
+                                            <p:txEl>
+                                              <p:pRg st="7" end="7"/>
+                                            </p:txEl>
+                                          </p:spTgt>
+                                        </p:tgtEl>
+                                        <p:attrNameLst>
+                                          <p:attrName>style.visibility</p:attrName>
+                                        </p:attrNameLst>
+                                      </p:cBhvr>
+                                      <p:to>
+                                        <p:strVal val="visible"/>
+                                      </p:to>
+                                    </p:set>
+                                  </p:childTnLst>
+                                </p:cTn>
+                              </p:par>
+                              <p:par>
+                                <p:cTn id="23" presetID="1" presetClass="entr" presetSubtype="0" fill="hold" nodeType="withEffect">
+                                  <p:stCondLst>
+                                    <p:cond delay="0"/>
+                                  </p:stCondLst>
+                                  <p:childTnLst>
+                                    <p:set>
+                                      <p:cBhvr>
+                                        <p:cTn id="24" dur="1" fill="hold">
+                                          <p:stCondLst>
+                                            <p:cond delay="0"/>
+                                          </p:stCondLst>
+                                        </p:cTn>
+                                        <p:tgtEl>
+                                          <p:spTgt spid="3">
+                                            <p:txEl>
+                                              <p:pRg st="8" end="8"/>
+                                            </p:txEl>
+                                          </p:spTgt>
+                                        </p:tgtEl>
+                                        <p:attrNameLst>
+                                          <p:attrName>style.visibility</p:attrName>
+                                        </p:attrNameLst>
+                                      </p:cBhvr>
+                                      <p:to>
+                                        <p:strVal val="visible"/>
+                                      </p:to>
+                                    </p:set>
+                                  </p:childTnLst>
+                                </p:cTn>
+                              </p:par>
+                            </p:childTnLst>
+                          </p:cTn>
+                        </p:par>
+                      </p:childTnLst>
+                    </p:cTn>
+                  </p:par>
+                </p:childTnLst>
+              </p:cTn>
+              <p:prevCondLst>
+                <p:cond evt="onPrev" delay="0">
+                  <p:tgtEl>
+                    <p:sldTgt/>
+                  </p:tgtEl>
+                </p:cond>
+              </p:prevCondLst>
+              <p:nextCondLst>
+                <p:cond evt="onNext" delay="0">
+                  <p:tgtEl>
+                    <p:sldTgt/>
+                  </p:tgtEl>
+                </p:cond>
+              </p:nextCondLst>
+            </p:seq>
+          </p:childTnLst>
+        </p:cTn>
+      </p:par>
+    </p:tnLst>
+  </p:timing>
 </p:sld>
 </file>
 
@@ -16093,7 +16426,7 @@
                           <m:nor/>
                         </m:rPr>
                         <a:rPr lang="en-US" i="0" dirty="0"/>
-                        <m:t>𝑃( 𝑝𝑎𝑟𝑎𝑚𝑒𝑡𝑒𝑟𝑠 │ 𝑑𝑎𝑡𝑎 )</m:t>
+                        <m:t>𝑃( ���𝑎𝑟𝑎𝑚𝑒𝑡𝑒𝑟𝑠 │ ���𝑎𝑡𝑎 )</m:t>
                       </m:r>
                       <m:r>
                         <a:rPr lang="en-US" i="1">
@@ -16107,7 +16440,7 @@
                           <m:nor/>
                         </m:rPr>
                         <a:rPr lang="en-US" i="0" dirty="0"/>
-                        <m:t>𝑃( 𝑑𝑎𝑡𝑎 | 𝑝𝑎𝑟𝑎𝑚𝑒𝑡𝑒𝑟𝑠 )𝑃( 𝑝𝑎𝑟𝑎𝑚𝑒𝑡𝑒𝑟𝑠 )</m:t>
+                        <m:t>𝑃( ���𝑎𝑡𝑎 | ���𝑎𝑟𝑎𝑚𝑒𝑡𝑒𝑟𝑠 )���( ���𝑎𝑟𝑎𝑚𝑒𝑡𝑒𝑟𝑠 )</m:t>
                       </m:r>
                     </m:oMath>
                   </m:oMathPara>
@@ -18153,8 +18486,8 @@
         </p:nvSpPr>
         <p:spPr>
           <a:xfrm>
-            <a:off x="6717376" y="1748498"/>
-            <a:ext cx="2269375" cy="1200329"/>
+            <a:off x="6674020" y="1569810"/>
+            <a:ext cx="2269375" cy="1477328"/>
           </a:xfrm>
           <a:prstGeom prst="rect">
             <a:avLst/>
@@ -18173,7 +18506,7 @@
             </a:pPr>
             <a:r>
               <a:rPr lang="en-US" dirty="0"/>
-              <a:t>Current belief, or posterior distribution, used as prior</a:t>
+              <a:t>Current belief, or posterior distribution from prior model, used as prior</a:t>
             </a:r>
           </a:p>
         </p:txBody>
@@ -18266,14 +18599,15 @@
             </a:extLst>
           </p:cNvPr>
           <p:cNvCxnSpPr>
+            <a:cxnSpLocks/>
             <a:stCxn id="6" idx="2"/>
           </p:cNvCxnSpPr>
           <p:nvPr/>
         </p:nvCxnSpPr>
         <p:spPr>
           <a:xfrm flipH="1">
-            <a:off x="7198822" y="2948827"/>
-            <a:ext cx="653242" cy="442766"/>
+            <a:off x="6964417" y="3047138"/>
+            <a:ext cx="844291" cy="344455"/>
           </a:xfrm>
           <a:prstGeom prst="straightConnector1">
             <a:avLst/>
@@ -20242,11 +20576,19 @@
             <a:pPr lvl="1"/>
             <a:r>
               <a:rPr dirty="0"/>
-              <a:t>One possibility is a Uniform distribution. But </a:t>
+              <a:t>One possibility is a Uniform distribution</a:t>
+            </a:r>
+            <a:endParaRPr lang="en-US" dirty="0"/>
+          </a:p>
+          <a:p>
+            <a:pPr lvl="1"/>
+            <a:r>
+              <a:rPr lang="en-US" b="1" dirty="0"/>
+              <a:t>B</a:t>
             </a:r>
             <a:r>
               <a:rPr b="1" dirty="0"/>
-              <a:t>be careful</a:t>
+              <a:t>e careful</a:t>
             </a:r>
             <a:r>
               <a:rPr lang="en-US" b="1" dirty="0"/>
@@ -20627,6 +20969,37 @@
                                   </p:childTnLst>
                                 </p:cTn>
                               </p:par>
+                              <p:par>
+                                <p:cTn id="27" presetID="1" presetClass="entr" presetSubtype="0" fill="hold" nodeType="withEffect">
+                                  <p:stCondLst>
+                                    <p:cond delay="0"/>
+                                  </p:stCondLst>
+                                  <p:childTnLst>
+                                    <p:set>
+                                      <p:cBhvr>
+                                        <p:cTn id="28" dur="1" fill="hold">
+                                          <p:stCondLst>
+                                            <p:cond delay="0"/>
+                                          </p:stCondLst>
+                                        </p:cTn>
+                                        <p:tgtEl>
+                                          <p:spTgt spid="3">
+                                            <p:txEl>
+                                              <p:pRg st="10" end="10"/>
+                                            </p:txEl>
+                                          </p:spTgt>
+                                        </p:tgtEl>
+                                        <p:attrNameLst>
+                                          <p:attrName>style.visibility</p:attrName>
+                                        </p:attrNameLst>
+                                      </p:cBhvr>
+                                      <p:to>
+                                        <p:strVal val="visible"/>
+                                      </p:to>
+                                    </p:set>
+                                  </p:childTnLst>
+                                </p:cTn>
+                              </p:par>
                             </p:childTnLst>
                           </p:cTn>
                         </p:par>
@@ -21551,8 +21924,13 @@
             <a:pPr lvl="0"/>
             <a:r>
               <a:rPr dirty="0"/>
-              <a:t>But there are many practical cases where a conjugate prior is not used</a:t>
-            </a:r>
+              <a:t>But there are many practical cases where a conjugate prior is not </a:t>
+            </a:r>
+            <a:r>
+              <a:rPr lang="en-US" dirty="0"/>
+              <a:t>known</a:t>
+            </a:r>
+            <a:endParaRPr dirty="0"/>
           </a:p>
           <a:p>
             <a:pPr lvl="1"/>
@@ -29874,8 +30252,8 @@
           </a:p>
         </p:txBody>
       </p:sp>
-      <mc:AlternateContent xmlns:mc="http://schemas.openxmlformats.org/markup-compatibility/2006" xmlns:a14="http://schemas.microsoft.com/office/drawing/2010/main">
-        <mc:Choice Requires="a14">
+      <mc:AlternateContent xmlns:mc="http://schemas.openxmlformats.org/markup-compatibility/2006">
+        <mc:Choice xmlns:a14="http://schemas.microsoft.com/office/drawing/2010/main" Requires="a14">
           <p:sp>
             <p:nvSpPr>
               <p:cNvPr id="3" name="Content Placeholder 2"/>
@@ -29974,7 +30352,15 @@
                 <a:pPr lvl="1"/>
                 <a:r>
                   <a:rPr dirty="0"/>
-                  <a:t>We use a concept known as the </a:t>
+                  <a:t>We </a:t>
+                </a:r>
+                <a:r>
+                  <a:rPr lang="en-US" dirty="0"/>
+                  <a:t>measure</a:t>
+                </a:r>
+                <a:r>
+                  <a:rPr dirty="0"/>
+                  <a:t> the </a:t>
                 </a:r>
                 <a:r>
                   <a:rPr b="1" dirty="0"/>
@@ -30029,7 +30415,7 @@
             </p:txBody>
           </p:sp>
         </mc:Choice>
-        <mc:Fallback xmlns="">
+        <mc:Fallback>
           <p:sp>
             <p:nvSpPr>
               <p:cNvPr id="3" name="Content Placeholder 2"/>
@@ -30048,7 +30434,7 @@
               <a:blipFill>
                 <a:blip r:embed="rId2"/>
                 <a:stretch>
-                  <a:fillRect l="-963" t="-2564" b="-302"/>
+                  <a:fillRect l="-963" t="-2564"/>
                 </a:stretch>
               </a:blipFill>
             </p:spPr>
@@ -31396,8 +31782,8 @@
           </a:p>
         </p:txBody>
       </p:sp>
-      <mc:AlternateContent xmlns:mc="http://schemas.openxmlformats.org/markup-compatibility/2006" xmlns:a14="http://schemas.microsoft.com/office/drawing/2010/main">
-        <mc:Choice Requires="a14">
+      <mc:AlternateContent xmlns:mc="http://schemas.openxmlformats.org/markup-compatibility/2006">
+        <mc:Choice xmlns:a14="http://schemas.microsoft.com/office/drawing/2010/main" Requires="a14">
           <p:sp>
             <p:nvSpPr>
               <p:cNvPr id="3" name="Content Placeholder 2"/>
@@ -31416,7 +31802,7 @@
             </p:spPr>
             <p:txBody>
               <a:bodyPr>
-                <a:normAutofit fontScale="92500"/>
+                <a:normAutofit fontScale="92500" lnSpcReduction="10000"/>
               </a:bodyPr>
               <a:lstStyle/>
               <a:p>
@@ -31480,7 +31866,7 @@
                 </a:r>
                 <a:r>
                   <a:rPr lang="en-US" dirty="0"/>
-                  <a:t> a confidence interval as an interval on a population distribution of a statistic!</a:t>
+                  <a:t> a confidence interval as an interval on the posterior distribution of a statistic!</a:t>
                 </a:r>
               </a:p>
               <a:p>
@@ -31518,13 +31904,13 @@
                 <a:pPr lvl="1"/>
                 <a:r>
                   <a:rPr lang="en-US" dirty="0"/>
-                  <a:t>Credible interval is exactly what would like the confidence interval to be</a:t>
+                  <a:t>Credible interval is exactly what intuition would like the confidence interval to be</a:t>
                 </a:r>
               </a:p>
             </p:txBody>
           </p:sp>
         </mc:Choice>
-        <mc:Fallback xmlns="">
+        <mc:Fallback>
           <p:sp>
             <p:nvSpPr>
               <p:cNvPr id="3" name="Content Placeholder 2"/>
@@ -31543,7 +31929,7 @@
               <a:blipFill>
                 <a:blip r:embed="rId2"/>
                 <a:stretch>
-                  <a:fillRect l="-963" t="-1037" r="-593"/>
+                  <a:fillRect l="-963" t="-1926" r="-1185"/>
                 </a:stretch>
               </a:blipFill>
             </p:spPr>
@@ -32597,6 +32983,76 @@
 </file>
 
 <file path=ppt/slides/slide66.xml><?xml version="1.0" encoding="utf-8"?>
+<p:sld xmlns:a="http://schemas.openxmlformats.org/drawingml/2006/main" xmlns:r="http://schemas.openxmlformats.org/officeDocument/2006/relationships" xmlns:p="http://schemas.openxmlformats.org/presentationml/2006/main">
+  <p:cSld>
+    <p:spTree>
+      <p:nvGrpSpPr>
+        <p:cNvPr id="1" name="">
+          <a:extLst>
+            <a:ext uri="{FF2B5EF4-FFF2-40B4-BE49-F238E27FC236}">
+              <a16:creationId xmlns:a16="http://schemas.microsoft.com/office/drawing/2014/main" id="{5CA29155-1D6D-2EFF-9C96-E8FF3298E16E}"/>
+            </a:ext>
+          </a:extLst>
+        </p:cNvPr>
+        <p:cNvGrpSpPr/>
+        <p:nvPr/>
+      </p:nvGrpSpPr>
+      <p:grpSpPr>
+        <a:xfrm>
+          <a:off x="0" y="0"/>
+          <a:ext cx="0" cy="0"/>
+          <a:chOff x="0" y="0"/>
+          <a:chExt cx="0" cy="0"/>
+        </a:xfrm>
+      </p:grpSpPr>
+      <p:sp>
+        <p:nvSpPr>
+          <p:cNvPr id="2" name="Title 1">
+            <a:extLst>
+              <a:ext uri="{FF2B5EF4-FFF2-40B4-BE49-F238E27FC236}">
+                <a16:creationId xmlns:a16="http://schemas.microsoft.com/office/drawing/2014/main" id="{9D31F7C6-3603-9050-217C-EE393677101C}"/>
+              </a:ext>
+            </a:extLst>
+          </p:cNvPr>
+          <p:cNvSpPr>
+            <a:spLocks noGrp="1"/>
+          </p:cNvSpPr>
+          <p:nvPr>
+            <p:ph type="title"/>
+          </p:nvPr>
+        </p:nvSpPr>
+        <p:spPr>
+          <a:xfrm>
+            <a:off x="817910" y="2232834"/>
+            <a:ext cx="7772400" cy="1021556"/>
+          </a:xfrm>
+        </p:spPr>
+        <p:txBody>
+          <a:bodyPr/>
+          <a:lstStyle/>
+          <a:p>
+            <a:pPr algn="ctr"/>
+            <a:r>
+              <a:rPr lang="en-US" cap="none" dirty="0"/>
+              <a:t>Summary</a:t>
+            </a:r>
+          </a:p>
+        </p:txBody>
+      </p:sp>
+    </p:spTree>
+    <p:extLst>
+      <p:ext uri="{BB962C8B-B14F-4D97-AF65-F5344CB8AC3E}">
+        <p14:creationId xmlns:p14="http://schemas.microsoft.com/office/powerpoint/2010/main" val="2906078416"/>
+      </p:ext>
+    </p:extLst>
+  </p:cSld>
+  <p:clrMapOvr>
+    <a:masterClrMapping/>
+  </p:clrMapOvr>
+</p:sld>
+</file>
+
+<file path=ppt/slides/slide67.xml><?xml version="1.0" encoding="utf-8"?>
 <p:sld xmlns:a="http://schemas.openxmlformats.org/drawingml/2006/main" xmlns:r="http://schemas.openxmlformats.org/officeDocument/2006/relationships" xmlns:p="http://schemas.openxmlformats.org/presentationml/2006/main">
   <p:cSld>
     <p:spTree>

</xml_diff>

<commit_message>
Typo correction from lecture
</commit_message>
<xml_diff>
--- a/LectureSlides/07_IntroductionToBayesModels.pptx
+++ b/LectureSlides/07_IntroductionToBayesModels.pptx
@@ -28620,11 +28620,11 @@
             </a:r>
             <a:r>
               <a:rPr lang="en-US" dirty="0"/>
-              <a:t>or Markov chain </a:t>
+              <a:t>or </a:t>
             </a:r>
             <a:r>
               <a:rPr lang="en-US" b="1" dirty="0"/>
-              <a:t>Monte Carlo (MCMC) sample</a:t>
+              <a:t>Markov chain Monte Carlo (MCMC) sample</a:t>
             </a:r>
             <a:endParaRPr b="1" dirty="0"/>
           </a:p>

</xml_diff>

<commit_message>
Updated plot in the simulation section of sldies
</commit_message>
<xml_diff>
--- a/LectureSlides/07_IntroductionToBayesModels.pptx
+++ b/LectureSlides/07_IntroductionToBayesModels.pptx
@@ -3878,8 +3878,8 @@
           </a:p>
         </p:txBody>
       </p:sp>
-      <mc:AlternateContent xmlns:mc="http://schemas.openxmlformats.org/markup-compatibility/2006">
-        <mc:Choice xmlns:a14="http://schemas.microsoft.com/office/drawing/2010/main" Requires="a14">
+      <mc:AlternateContent xmlns:mc="http://schemas.openxmlformats.org/markup-compatibility/2006" xmlns:a14="http://schemas.microsoft.com/office/drawing/2010/main">
+        <mc:Choice Requires="a14">
           <p:sp>
             <p:nvSpPr>
               <p:cNvPr id="6" name="Content Placeholder 2"/>
@@ -4146,14 +4146,7 @@
                       <a:rPr lang="en-US" b="0" i="0" smtClean="0">
                         <a:latin typeface="Cambria Math" panose="02040503050406030204" pitchFamily="18" charset="0"/>
                       </a:rPr>
-                      <m:t>=</m:t>
-                    </m:r>
-                    <m:r>
-                      <a:rPr lang="en-US" b="0" i="1" smtClean="0">
-                        <a:latin typeface="Cambria Math" panose="02040503050406030204" pitchFamily="18" charset="0"/>
-                        <a:ea typeface="Cambria Math" panose="02040503050406030204" pitchFamily="18" charset="0"/>
-                      </a:rPr>
-                      <m:t>∅</m:t>
+                      <m:t>=∅</m:t>
                     </m:r>
                   </m:oMath>
                 </a14:m>
@@ -4325,7 +4318,7 @@
             </p:txBody>
           </p:sp>
         </mc:Choice>
-        <mc:Fallback>
+        <mc:Fallback xmlns="">
           <p:sp>
             <p:nvSpPr>
               <p:cNvPr id="6" name="Content Placeholder 2"/>
@@ -7938,8 +7931,8 @@
           </a:p>
         </p:txBody>
       </p:sp>
-      <mc:AlternateContent xmlns:mc="http://schemas.openxmlformats.org/markup-compatibility/2006">
-        <mc:Choice xmlns:a14="http://schemas.microsoft.com/office/drawing/2010/main" Requires="a14">
+      <mc:AlternateContent xmlns:mc="http://schemas.openxmlformats.org/markup-compatibility/2006" xmlns:a14="http://schemas.microsoft.com/office/drawing/2010/main">
+        <mc:Choice Requires="a14">
           <p:sp>
             <p:nvSpPr>
               <p:cNvPr id="3" name="Content Placeholder 2"/>
@@ -8251,7 +8244,7 @@
             </p:txBody>
           </p:sp>
         </mc:Choice>
-        <mc:Fallback>
+        <mc:Fallback xmlns="">
           <p:sp>
             <p:nvSpPr>
               <p:cNvPr id="3" name="Content Placeholder 2"/>
@@ -8554,8 +8547,8 @@
           </a:p>
         </p:txBody>
       </p:sp>
-      <mc:AlternateContent xmlns:mc="http://schemas.openxmlformats.org/markup-compatibility/2006">
-        <mc:Choice xmlns:a14="http://schemas.microsoft.com/office/drawing/2010/main" Requires="a14">
+      <mc:AlternateContent xmlns:mc="http://schemas.openxmlformats.org/markup-compatibility/2006" xmlns:a14="http://schemas.microsoft.com/office/drawing/2010/main">
+        <mc:Choice Requires="a14">
           <p:sp>
             <p:nvSpPr>
               <p:cNvPr id="3" name="Content Placeholder 2">
@@ -8864,7 +8857,7 @@
             </p:txBody>
           </p:sp>
         </mc:Choice>
-        <mc:Fallback>
+        <mc:Fallback xmlns="">
           <p:sp>
             <p:nvSpPr>
               <p:cNvPr id="3" name="Content Placeholder 2">
@@ -9178,8 +9171,8 @@
           </a:p>
         </p:txBody>
       </p:sp>
-      <mc:AlternateContent xmlns:mc="http://schemas.openxmlformats.org/markup-compatibility/2006">
-        <mc:Choice xmlns:a14="http://schemas.microsoft.com/office/drawing/2010/main" Requires="a14">
+      <mc:AlternateContent xmlns:mc="http://schemas.openxmlformats.org/markup-compatibility/2006" xmlns:a14="http://schemas.microsoft.com/office/drawing/2010/main">
+        <mc:Choice Requires="a14">
           <p:sp>
             <p:nvSpPr>
               <p:cNvPr id="3" name="Content Placeholder 2">
@@ -9468,7 +9461,7 @@
             </p:txBody>
           </p:sp>
         </mc:Choice>
-        <mc:Fallback>
+        <mc:Fallback xmlns="">
           <p:sp>
             <p:nvSpPr>
               <p:cNvPr id="3" name="Content Placeholder 2">
@@ -9839,8 +9832,8 @@
           </a:p>
         </p:txBody>
       </p:sp>
-      <mc:AlternateContent xmlns:mc="http://schemas.openxmlformats.org/markup-compatibility/2006">
-        <mc:Choice xmlns:a14="http://schemas.microsoft.com/office/drawing/2010/main" Requires="a14">
+      <mc:AlternateContent xmlns:mc="http://schemas.openxmlformats.org/markup-compatibility/2006" xmlns:a14="http://schemas.microsoft.com/office/drawing/2010/main">
+        <mc:Choice Requires="a14">
           <p:sp>
             <p:nvSpPr>
               <p:cNvPr id="3" name="Content Placeholder 2">
@@ -10109,7 +10102,7 @@
             </p:txBody>
           </p:sp>
         </mc:Choice>
-        <mc:Fallback>
+        <mc:Fallback xmlns="">
           <p:sp>
             <p:nvSpPr>
               <p:cNvPr id="3" name="Content Placeholder 2">
@@ -12146,8 +12139,8 @@
           </a:p>
         </p:txBody>
       </p:sp>
-      <mc:AlternateContent xmlns:mc="http://schemas.openxmlformats.org/markup-compatibility/2006">
-        <mc:Choice xmlns:a14="http://schemas.microsoft.com/office/drawing/2010/main" Requires="a14">
+      <mc:AlternateContent xmlns:mc="http://schemas.openxmlformats.org/markup-compatibility/2006" xmlns:a14="http://schemas.microsoft.com/office/drawing/2010/main">
+        <mc:Choice Requires="a14">
           <p:sp>
             <p:nvSpPr>
               <p:cNvPr id="3" name="Content Placeholder 2"/>
@@ -12783,7 +12776,7 @@
             </p:txBody>
           </p:sp>
         </mc:Choice>
-        <mc:Fallback>
+        <mc:Fallback xmlns="">
           <p:sp>
             <p:nvSpPr>
               <p:cNvPr id="3" name="Content Placeholder 2"/>
@@ -20588,8 +20581,8 @@
           </a:p>
         </p:txBody>
       </p:sp>
-      <mc:AlternateContent xmlns:mc="http://schemas.openxmlformats.org/markup-compatibility/2006">
-        <mc:Choice xmlns:a14="http://schemas.microsoft.com/office/drawing/2010/main" Requires="a14">
+      <mc:AlternateContent xmlns:mc="http://schemas.openxmlformats.org/markup-compatibility/2006" xmlns:a14="http://schemas.microsoft.com/office/drawing/2010/main">
+        <mc:Choice Requires="a14">
           <p:sp>
             <p:nvSpPr>
               <p:cNvPr id="3" name="Content Placeholder 2"/>
@@ -20800,7 +20793,7 @@
             </p:txBody>
           </p:sp>
         </mc:Choice>
-        <mc:Fallback>
+        <mc:Fallback xmlns="">
           <p:sp>
             <p:nvSpPr>
               <p:cNvPr id="3" name="Content Placeholder 2"/>
@@ -24329,8 +24322,8 @@
           </a:p>
         </p:txBody>
       </p:sp>
-      <mc:AlternateContent xmlns:mc="http://schemas.openxmlformats.org/markup-compatibility/2006">
-        <mc:Choice xmlns:a14="http://schemas.microsoft.com/office/drawing/2010/main" Requires="a14">
+      <mc:AlternateContent xmlns:mc="http://schemas.openxmlformats.org/markup-compatibility/2006" xmlns:a14="http://schemas.microsoft.com/office/drawing/2010/main">
+        <mc:Choice Requires="a14">
           <p:sp>
             <p:nvSpPr>
               <p:cNvPr id="3" name="Content Placeholder 2"/>
@@ -24499,7 +24492,7 @@
             </p:txBody>
           </p:sp>
         </mc:Choice>
-        <mc:Fallback>
+        <mc:Fallback xmlns="">
           <p:sp>
             <p:nvSpPr>
               <p:cNvPr id="3" name="Content Placeholder 2"/>
@@ -30588,8 +30581,8 @@
           </a:p>
         </p:txBody>
       </p:sp>
-      <mc:AlternateContent xmlns:mc="http://schemas.openxmlformats.org/markup-compatibility/2006">
-        <mc:Choice xmlns:a14="http://schemas.microsoft.com/office/drawing/2010/main" Requires="a14">
+      <mc:AlternateContent xmlns:mc="http://schemas.openxmlformats.org/markup-compatibility/2006" xmlns:a14="http://schemas.microsoft.com/office/drawing/2010/main">
+        <mc:Choice Requires="a14">
           <p:sp>
             <p:nvSpPr>
               <p:cNvPr id="3" name="Content Placeholder 2"/>
@@ -30755,7 +30748,7 @@
             </p:txBody>
           </p:sp>
         </mc:Choice>
-        <mc:Fallback>
+        <mc:Fallback xmlns="">
           <p:sp>
             <p:nvSpPr>
               <p:cNvPr id="3" name="Content Placeholder 2"/>
@@ -32130,8 +32123,8 @@
           </a:p>
         </p:txBody>
       </p:sp>
-      <mc:AlternateContent xmlns:mc="http://schemas.openxmlformats.org/markup-compatibility/2006">
-        <mc:Choice xmlns:a14="http://schemas.microsoft.com/office/drawing/2010/main" Requires="a14">
+      <mc:AlternateContent xmlns:mc="http://schemas.openxmlformats.org/markup-compatibility/2006" xmlns:a14="http://schemas.microsoft.com/office/drawing/2010/main">
+        <mc:Choice Requires="a14">
           <p:sp>
             <p:nvSpPr>
               <p:cNvPr id="3" name="Content Placeholder 2"/>
@@ -32258,7 +32251,7 @@
             </p:txBody>
           </p:sp>
         </mc:Choice>
-        <mc:Fallback>
+        <mc:Fallback xmlns="">
           <p:sp>
             <p:nvSpPr>
               <p:cNvPr id="3" name="Content Placeholder 2"/>
@@ -33191,7 +33184,7 @@
                 </a:r>
                 <a:r>
                   <a:rPr lang="en-US" dirty="0"/>
-                  <a:t>Are the expected numbers </a:t>
+                  <a:t>Are the probability of the number </a:t>
                 </a:r>
                 <a:r>
                   <a:rPr dirty="0"/>
@@ -33303,7 +33296,7 @@
             </a:pPr>
             <a:r>
               <a:rPr lang="en-US" dirty="0"/>
-              <a:t>Exepected numbers </a:t>
+              <a:t>Probability of number </a:t>
             </a:r>
             <a:r>
               <a:rPr dirty="0"/>
@@ -33314,10 +33307,10 @@
       </p:sp>
       <p:pic>
         <p:nvPicPr>
-          <p:cNvPr id="7" name="Picture 6">
+          <p:cNvPr id="6" name="Picture 5">
             <a:extLst>
               <a:ext uri="{FF2B5EF4-FFF2-40B4-BE49-F238E27FC236}">
-                <a16:creationId xmlns:a16="http://schemas.microsoft.com/office/drawing/2014/main" id="{E05A3C24-6094-C377-5527-793942218E99}"/>
+                <a16:creationId xmlns:a16="http://schemas.microsoft.com/office/drawing/2014/main" id="{D9C6E955-E261-B87A-60E7-3F756D3D89B8}"/>
               </a:ext>
             </a:extLst>
           </p:cNvPr>
@@ -33334,8 +33327,8 @@
         </p:blipFill>
         <p:spPr>
           <a:xfrm>
-            <a:off x="2689665" y="1911459"/>
-            <a:ext cx="3476572" cy="2858514"/>
+            <a:off x="2676197" y="1786372"/>
+            <a:ext cx="3747442" cy="2945172"/>
           </a:xfrm>
           <a:prstGeom prst="rect">
             <a:avLst/>

</xml_diff>